<commit_message>
Updating a bunch of pages.
</commit_message>
<xml_diff>
--- a/layout/new_github_website_layout_AI.pptx
+++ b/layout/new_github_website_layout_AI.pptx
@@ -7,6 +7,7 @@
   <p:sldIdLst>
     <p:sldId id="256" r:id="rId2"/>
     <p:sldId id="257" r:id="rId3"/>
+    <p:sldId id="258" r:id="rId4"/>
   </p:sldIdLst>
   <p:sldSz cx="8412163" cy="10240963"/>
   <p:notesSz cx="6858000" cy="9144000"/>
@@ -244,7 +245,7 @@
           <a:p>
             <a:fld id="{F67B4DC1-61A9-4B5F-908F-A6BF40921A54}" type="datetimeFigureOut">
               <a:rPr lang="en-US" smtClean="0"/>
-              <a:t>9/30/2025</a:t>
+              <a:t>10/13/2025</a:t>
             </a:fld>
             <a:endParaRPr lang="en-US"/>
           </a:p>
@@ -414,7 +415,7 @@
           <a:p>
             <a:fld id="{F67B4DC1-61A9-4B5F-908F-A6BF40921A54}" type="datetimeFigureOut">
               <a:rPr lang="en-US" smtClean="0"/>
-              <a:t>9/30/2025</a:t>
+              <a:t>10/13/2025</a:t>
             </a:fld>
             <a:endParaRPr lang="en-US"/>
           </a:p>
@@ -594,7 +595,7 @@
           <a:p>
             <a:fld id="{F67B4DC1-61A9-4B5F-908F-A6BF40921A54}" type="datetimeFigureOut">
               <a:rPr lang="en-US" smtClean="0"/>
-              <a:t>9/30/2025</a:t>
+              <a:t>10/13/2025</a:t>
             </a:fld>
             <a:endParaRPr lang="en-US"/>
           </a:p>
@@ -764,7 +765,7 @@
           <a:p>
             <a:fld id="{F67B4DC1-61A9-4B5F-908F-A6BF40921A54}" type="datetimeFigureOut">
               <a:rPr lang="en-US" smtClean="0"/>
-              <a:t>9/30/2025</a:t>
+              <a:t>10/13/2025</a:t>
             </a:fld>
             <a:endParaRPr lang="en-US"/>
           </a:p>
@@ -1010,7 +1011,7 @@
           <a:p>
             <a:fld id="{F67B4DC1-61A9-4B5F-908F-A6BF40921A54}" type="datetimeFigureOut">
               <a:rPr lang="en-US" smtClean="0"/>
-              <a:t>9/30/2025</a:t>
+              <a:t>10/13/2025</a:t>
             </a:fld>
             <a:endParaRPr lang="en-US"/>
           </a:p>
@@ -1242,7 +1243,7 @@
           <a:p>
             <a:fld id="{F67B4DC1-61A9-4B5F-908F-A6BF40921A54}" type="datetimeFigureOut">
               <a:rPr lang="en-US" smtClean="0"/>
-              <a:t>9/30/2025</a:t>
+              <a:t>10/13/2025</a:t>
             </a:fld>
             <a:endParaRPr lang="en-US"/>
           </a:p>
@@ -1609,7 +1610,7 @@
           <a:p>
             <a:fld id="{F67B4DC1-61A9-4B5F-908F-A6BF40921A54}" type="datetimeFigureOut">
               <a:rPr lang="en-US" smtClean="0"/>
-              <a:t>9/30/2025</a:t>
+              <a:t>10/13/2025</a:t>
             </a:fld>
             <a:endParaRPr lang="en-US"/>
           </a:p>
@@ -1727,7 +1728,7 @@
           <a:p>
             <a:fld id="{F67B4DC1-61A9-4B5F-908F-A6BF40921A54}" type="datetimeFigureOut">
               <a:rPr lang="en-US" smtClean="0"/>
-              <a:t>9/30/2025</a:t>
+              <a:t>10/13/2025</a:t>
             </a:fld>
             <a:endParaRPr lang="en-US"/>
           </a:p>
@@ -1822,7 +1823,7 @@
           <a:p>
             <a:fld id="{F67B4DC1-61A9-4B5F-908F-A6BF40921A54}" type="datetimeFigureOut">
               <a:rPr lang="en-US" smtClean="0"/>
-              <a:t>9/30/2025</a:t>
+              <a:t>10/13/2025</a:t>
             </a:fld>
             <a:endParaRPr lang="en-US"/>
           </a:p>
@@ -2099,7 +2100,7 @@
           <a:p>
             <a:fld id="{F67B4DC1-61A9-4B5F-908F-A6BF40921A54}" type="datetimeFigureOut">
               <a:rPr lang="en-US" smtClean="0"/>
-              <a:t>9/30/2025</a:t>
+              <a:t>10/13/2025</a:t>
             </a:fld>
             <a:endParaRPr lang="en-US"/>
           </a:p>
@@ -2356,7 +2357,7 @@
           <a:p>
             <a:fld id="{F67B4DC1-61A9-4B5F-908F-A6BF40921A54}" type="datetimeFigureOut">
               <a:rPr lang="en-US" smtClean="0"/>
-              <a:t>9/30/2025</a:t>
+              <a:t>10/13/2025</a:t>
             </a:fld>
             <a:endParaRPr lang="en-US"/>
           </a:p>
@@ -2569,7 +2570,7 @@
           <a:p>
             <a:fld id="{F67B4DC1-61A9-4B5F-908F-A6BF40921A54}" type="datetimeFigureOut">
               <a:rPr lang="en-US" smtClean="0"/>
-              <a:t>9/30/2025</a:t>
+              <a:t>10/13/2025</a:t>
             </a:fld>
             <a:endParaRPr lang="en-US"/>
           </a:p>
@@ -4731,7 +4732,7 @@
                     <a:schemeClr val="tx1"/>
                   </a:solidFill>
                 </a:rPr>
-                <a:t>Address and copyright information</a:t>
+                <a:t>Footer: Address and copyright information</a:t>
               </a:r>
             </a:p>
           </p:txBody>
@@ -5116,7 +5117,7 @@
           <p:spPr>
             <a:xfrm>
               <a:off x="1225356" y="4043242"/>
-              <a:ext cx="5123358" cy="2234657"/>
+              <a:ext cx="5920964" cy="2234657"/>
             </a:xfrm>
             <a:prstGeom prst="rect">
               <a:avLst/>
@@ -5193,7 +5194,7 @@
           </p:nvSpPr>
           <p:spPr>
             <a:xfrm>
-              <a:off x="6916321" y="1497506"/>
+              <a:off x="7301247" y="1483088"/>
               <a:ext cx="298192" cy="227896"/>
             </a:xfrm>
             <a:prstGeom prst="rect">
@@ -5224,7 +5225,7 @@
             <a:lstStyle/>
             <a:p>
               <a:pPr algn="ctr"/>
-              <a:endParaRPr lang="en-US" sz="1600"/>
+              <a:endParaRPr lang="en-US" sz="1600" dirty="0"/>
             </a:p>
           </p:txBody>
         </p:sp>
@@ -5242,56 +5243,7 @@
           </p:nvSpPr>
           <p:spPr>
             <a:xfrm>
-              <a:off x="7880229" y="1484226"/>
-              <a:ext cx="298192" cy="227896"/>
-            </a:xfrm>
-            <a:prstGeom prst="rect">
-              <a:avLst/>
-            </a:prstGeom>
-            <a:solidFill>
-              <a:srgbClr val="FF0000"/>
-            </a:solidFill>
-          </p:spPr>
-          <p:style>
-            <a:lnRef idx="2">
-              <a:schemeClr val="accent1">
-                <a:shade val="15000"/>
-              </a:schemeClr>
-            </a:lnRef>
-            <a:fillRef idx="1">
-              <a:schemeClr val="accent1"/>
-            </a:fillRef>
-            <a:effectRef idx="0">
-              <a:schemeClr val="accent1"/>
-            </a:effectRef>
-            <a:fontRef idx="minor">
-              <a:schemeClr val="lt1"/>
-            </a:fontRef>
-          </p:style>
-          <p:txBody>
-            <a:bodyPr rtlCol="0" anchor="ctr"/>
-            <a:lstStyle/>
-            <a:p>
-              <a:pPr algn="ctr"/>
-              <a:endParaRPr lang="en-US" sz="1600"/>
-            </a:p>
-          </p:txBody>
-        </p:sp>
-        <p:sp>
-          <p:nvSpPr>
-            <p:cNvPr id="35" name="Rectangle 34">
-              <a:extLst>
-                <a:ext uri="{FF2B5EF4-FFF2-40B4-BE49-F238E27FC236}">
-                  <a16:creationId xmlns:a16="http://schemas.microsoft.com/office/drawing/2014/main" id="{D7DEEA3F-E5B9-1D11-6C1E-71A3EF73B05C}"/>
-                </a:ext>
-              </a:extLst>
-            </p:cNvPr>
-            <p:cNvSpPr/>
-            <p:nvPr/>
-          </p:nvSpPr>
-          <p:spPr>
-            <a:xfrm>
-              <a:off x="7398275" y="1480222"/>
+              <a:off x="7717633" y="1483088"/>
               <a:ext cx="298192" cy="227896"/>
             </a:xfrm>
             <a:prstGeom prst="rect">
@@ -6143,10 +6095,1888 @@
           </p:txBody>
         </p:sp>
       </p:grpSp>
+      <p:sp>
+        <p:nvSpPr>
+          <p:cNvPr id="4" name="Rectangle 3">
+            <a:extLst>
+              <a:ext uri="{FF2B5EF4-FFF2-40B4-BE49-F238E27FC236}">
+                <a16:creationId xmlns:a16="http://schemas.microsoft.com/office/drawing/2014/main" id="{1E54E0E4-B1FA-BE66-DC20-199B09288015}"/>
+              </a:ext>
+            </a:extLst>
+          </p:cNvPr>
+          <p:cNvSpPr/>
+          <p:nvPr/>
+        </p:nvSpPr>
+        <p:spPr>
+          <a:xfrm>
+            <a:off x="2987709" y="2001285"/>
+            <a:ext cx="1908564" cy="1729966"/>
+          </a:xfrm>
+          <a:prstGeom prst="rect">
+            <a:avLst/>
+          </a:prstGeom>
+          <a:noFill/>
+          <a:ln w="28575">
+            <a:solidFill>
+              <a:srgbClr val="FF9933"/>
+            </a:solidFill>
+            <a:prstDash val="sysDash"/>
+          </a:ln>
+        </p:spPr>
+        <p:style>
+          <a:lnRef idx="2">
+            <a:schemeClr val="accent1">
+              <a:shade val="15000"/>
+            </a:schemeClr>
+          </a:lnRef>
+          <a:fillRef idx="1">
+            <a:schemeClr val="accent1"/>
+          </a:fillRef>
+          <a:effectRef idx="0">
+            <a:schemeClr val="accent1"/>
+          </a:effectRef>
+          <a:fontRef idx="minor">
+            <a:schemeClr val="lt1"/>
+          </a:fontRef>
+        </p:style>
+        <p:txBody>
+          <a:bodyPr rtlCol="0" anchor="ctr"/>
+          <a:lstStyle/>
+          <a:p>
+            <a:pPr algn="ctr"/>
+            <a:endParaRPr lang="en-US"/>
+          </a:p>
+        </p:txBody>
+      </p:sp>
+      <p:sp>
+        <p:nvSpPr>
+          <p:cNvPr id="7" name="Rectangle 6">
+            <a:extLst>
+              <a:ext uri="{FF2B5EF4-FFF2-40B4-BE49-F238E27FC236}">
+                <a16:creationId xmlns:a16="http://schemas.microsoft.com/office/drawing/2014/main" id="{B67B3ADD-6E3E-EF13-9F00-A139617B6779}"/>
+              </a:ext>
+            </a:extLst>
+          </p:cNvPr>
+          <p:cNvSpPr/>
+          <p:nvPr/>
+        </p:nvSpPr>
+        <p:spPr>
+          <a:xfrm>
+            <a:off x="1265843" y="4104066"/>
+            <a:ext cx="3456281" cy="2036111"/>
+          </a:xfrm>
+          <a:prstGeom prst="rect">
+            <a:avLst/>
+          </a:prstGeom>
+          <a:noFill/>
+          <a:ln w="28575">
+            <a:solidFill>
+              <a:srgbClr val="FF9933"/>
+            </a:solidFill>
+            <a:prstDash val="sysDash"/>
+          </a:ln>
+        </p:spPr>
+        <p:style>
+          <a:lnRef idx="2">
+            <a:schemeClr val="accent1">
+              <a:shade val="15000"/>
+            </a:schemeClr>
+          </a:lnRef>
+          <a:fillRef idx="1">
+            <a:schemeClr val="accent1"/>
+          </a:fillRef>
+          <a:effectRef idx="0">
+            <a:schemeClr val="accent1"/>
+          </a:effectRef>
+          <a:fontRef idx="minor">
+            <a:schemeClr val="lt1"/>
+          </a:fontRef>
+        </p:style>
+        <p:txBody>
+          <a:bodyPr rtlCol="0" anchor="ctr"/>
+          <a:lstStyle/>
+          <a:p>
+            <a:pPr algn="ctr"/>
+            <a:endParaRPr lang="en-US"/>
+          </a:p>
+        </p:txBody>
+      </p:sp>
     </p:spTree>
     <p:extLst>
       <p:ext uri="{BB962C8B-B14F-4D97-AF65-F5344CB8AC3E}">
         <p14:creationId xmlns:p14="http://schemas.microsoft.com/office/powerpoint/2010/main" val="3005560059"/>
+      </p:ext>
+    </p:extLst>
+  </p:cSld>
+  <p:clrMapOvr>
+    <a:masterClrMapping/>
+  </p:clrMapOvr>
+</p:sld>
+</file>
+
+<file path=ppt/slides/slide3.xml><?xml version="1.0" encoding="utf-8"?>
+<p:sld xmlns:a="http://schemas.openxmlformats.org/drawingml/2006/main" xmlns:r="http://schemas.openxmlformats.org/officeDocument/2006/relationships" xmlns:p="http://schemas.openxmlformats.org/presentationml/2006/main">
+  <p:cSld>
+    <p:spTree>
+      <p:nvGrpSpPr>
+        <p:cNvPr id="1" name="">
+          <a:extLst>
+            <a:ext uri="{FF2B5EF4-FFF2-40B4-BE49-F238E27FC236}">
+              <a16:creationId xmlns:a16="http://schemas.microsoft.com/office/drawing/2014/main" id="{01397727-A0CF-57E7-CFD3-EEBCF87DCC69}"/>
+            </a:ext>
+          </a:extLst>
+        </p:cNvPr>
+        <p:cNvGrpSpPr/>
+        <p:nvPr/>
+      </p:nvGrpSpPr>
+      <p:grpSpPr>
+        <a:xfrm>
+          <a:off x="0" y="0"/>
+          <a:ext cx="0" cy="0"/>
+          <a:chOff x="0" y="0"/>
+          <a:chExt cx="0" cy="0"/>
+        </a:xfrm>
+      </p:grpSpPr>
+      <p:sp>
+        <p:nvSpPr>
+          <p:cNvPr id="3" name="TextBox 2">
+            <a:extLst>
+              <a:ext uri="{FF2B5EF4-FFF2-40B4-BE49-F238E27FC236}">
+                <a16:creationId xmlns:a16="http://schemas.microsoft.com/office/drawing/2014/main" id="{5BCBAE94-DE0B-A40F-4D85-F7A836B2D113}"/>
+              </a:ext>
+            </a:extLst>
+          </p:cNvPr>
+          <p:cNvSpPr txBox="1"/>
+          <p:nvPr/>
+        </p:nvSpPr>
+        <p:spPr>
+          <a:xfrm>
+            <a:off x="4252870" y="566416"/>
+            <a:ext cx="631904" cy="307777"/>
+          </a:xfrm>
+          <a:prstGeom prst="rect">
+            <a:avLst/>
+          </a:prstGeom>
+          <a:noFill/>
+        </p:spPr>
+        <p:txBody>
+          <a:bodyPr wrap="none" rtlCol="0">
+            <a:spAutoFit/>
+          </a:bodyPr>
+          <a:lstStyle/>
+          <a:p>
+            <a:r>
+              <a:rPr lang="en-US" sz="1400" dirty="0"/>
+              <a:t>home</a:t>
+            </a:r>
+          </a:p>
+        </p:txBody>
+      </p:sp>
+      <p:sp>
+        <p:nvSpPr>
+          <p:cNvPr id="5" name="TextBox 4">
+            <a:extLst>
+              <a:ext uri="{FF2B5EF4-FFF2-40B4-BE49-F238E27FC236}">
+                <a16:creationId xmlns:a16="http://schemas.microsoft.com/office/drawing/2014/main" id="{CC134F51-902B-AE44-9A67-5DFF8E06D47E}"/>
+              </a:ext>
+            </a:extLst>
+          </p:cNvPr>
+          <p:cNvSpPr txBox="1"/>
+          <p:nvPr/>
+        </p:nvSpPr>
+        <p:spPr>
+          <a:xfrm>
+            <a:off x="4877037" y="552137"/>
+            <a:ext cx="1199882" cy="307777"/>
+          </a:xfrm>
+          <a:prstGeom prst="rect">
+            <a:avLst/>
+          </a:prstGeom>
+          <a:noFill/>
+        </p:spPr>
+        <p:txBody>
+          <a:bodyPr wrap="square" rtlCol="0">
+            <a:spAutoFit/>
+          </a:bodyPr>
+          <a:lstStyle/>
+          <a:p>
+            <a:r>
+              <a:rPr lang="en-US" sz="1400" dirty="0"/>
+              <a:t>people</a:t>
+            </a:r>
+          </a:p>
+        </p:txBody>
+      </p:sp>
+      <p:sp>
+        <p:nvSpPr>
+          <p:cNvPr id="6" name="TextBox 5">
+            <a:extLst>
+              <a:ext uri="{FF2B5EF4-FFF2-40B4-BE49-F238E27FC236}">
+                <a16:creationId xmlns:a16="http://schemas.microsoft.com/office/drawing/2014/main" id="{83A91D64-E5CF-8414-807B-767100FF3493}"/>
+              </a:ext>
+            </a:extLst>
+          </p:cNvPr>
+          <p:cNvSpPr txBox="1"/>
+          <p:nvPr/>
+        </p:nvSpPr>
+        <p:spPr>
+          <a:xfrm>
+            <a:off x="5557774" y="559276"/>
+            <a:ext cx="817916" cy="307777"/>
+          </a:xfrm>
+          <a:prstGeom prst="rect">
+            <a:avLst/>
+          </a:prstGeom>
+          <a:noFill/>
+        </p:spPr>
+        <p:txBody>
+          <a:bodyPr wrap="none" rtlCol="0">
+            <a:spAutoFit/>
+          </a:bodyPr>
+          <a:lstStyle/>
+          <a:p>
+            <a:r>
+              <a:rPr lang="en-US" sz="1400" dirty="0"/>
+              <a:t>projects</a:t>
+            </a:r>
+          </a:p>
+        </p:txBody>
+      </p:sp>
+      <p:sp>
+        <p:nvSpPr>
+          <p:cNvPr id="8" name="TextBox 7">
+            <a:extLst>
+              <a:ext uri="{FF2B5EF4-FFF2-40B4-BE49-F238E27FC236}">
+                <a16:creationId xmlns:a16="http://schemas.microsoft.com/office/drawing/2014/main" id="{F9132BE7-8347-2964-8748-69E7530D88A2}"/>
+              </a:ext>
+            </a:extLst>
+          </p:cNvPr>
+          <p:cNvSpPr txBox="1"/>
+          <p:nvPr/>
+        </p:nvSpPr>
+        <p:spPr>
+          <a:xfrm>
+            <a:off x="7434056" y="544998"/>
+            <a:ext cx="783484" cy="307777"/>
+          </a:xfrm>
+          <a:prstGeom prst="rect">
+            <a:avLst/>
+          </a:prstGeom>
+          <a:noFill/>
+        </p:spPr>
+        <p:txBody>
+          <a:bodyPr wrap="none" rtlCol="0">
+            <a:spAutoFit/>
+          </a:bodyPr>
+          <a:lstStyle/>
+          <a:p>
+            <a:r>
+              <a:rPr lang="en-US" sz="1400" dirty="0"/>
+              <a:t>contact</a:t>
+            </a:r>
+          </a:p>
+        </p:txBody>
+      </p:sp>
+      <p:sp>
+        <p:nvSpPr>
+          <p:cNvPr id="20" name="TextBox 19">
+            <a:extLst>
+              <a:ext uri="{FF2B5EF4-FFF2-40B4-BE49-F238E27FC236}">
+                <a16:creationId xmlns:a16="http://schemas.microsoft.com/office/drawing/2014/main" id="{C0591A47-FF85-9246-D339-AF98442BEEB4}"/>
+              </a:ext>
+            </a:extLst>
+          </p:cNvPr>
+          <p:cNvSpPr txBox="1"/>
+          <p:nvPr/>
+        </p:nvSpPr>
+        <p:spPr>
+          <a:xfrm>
+            <a:off x="6316377" y="552137"/>
+            <a:ext cx="1151854" cy="307777"/>
+          </a:xfrm>
+          <a:prstGeom prst="rect">
+            <a:avLst/>
+          </a:prstGeom>
+          <a:noFill/>
+        </p:spPr>
+        <p:txBody>
+          <a:bodyPr wrap="none" rtlCol="0">
+            <a:spAutoFit/>
+          </a:bodyPr>
+          <a:lstStyle/>
+          <a:p>
+            <a:r>
+              <a:rPr lang="en-US" sz="1400" dirty="0"/>
+              <a:t>publications</a:t>
+            </a:r>
+          </a:p>
+        </p:txBody>
+      </p:sp>
+      <p:sp>
+        <p:nvSpPr>
+          <p:cNvPr id="21" name="Rectangle 20">
+            <a:extLst>
+              <a:ext uri="{FF2B5EF4-FFF2-40B4-BE49-F238E27FC236}">
+                <a16:creationId xmlns:a16="http://schemas.microsoft.com/office/drawing/2014/main" id="{450BB7AA-F8C3-7C36-A9E3-0509049118C1}"/>
+              </a:ext>
+            </a:extLst>
+          </p:cNvPr>
+          <p:cNvSpPr/>
+          <p:nvPr/>
+        </p:nvSpPr>
+        <p:spPr>
+          <a:xfrm>
+            <a:off x="179072" y="8742378"/>
+            <a:ext cx="7645377" cy="871378"/>
+          </a:xfrm>
+          <a:prstGeom prst="rect">
+            <a:avLst/>
+          </a:prstGeom>
+          <a:solidFill>
+            <a:schemeClr val="accent6">
+              <a:lumMod val="40000"/>
+              <a:lumOff val="60000"/>
+            </a:schemeClr>
+          </a:solidFill>
+          <a:ln>
+            <a:noFill/>
+          </a:ln>
+        </p:spPr>
+        <p:style>
+          <a:lnRef idx="2">
+            <a:schemeClr val="accent1">
+              <a:shade val="15000"/>
+            </a:schemeClr>
+          </a:lnRef>
+          <a:fillRef idx="1">
+            <a:schemeClr val="accent1"/>
+          </a:fillRef>
+          <a:effectRef idx="0">
+            <a:schemeClr val="accent1"/>
+          </a:effectRef>
+          <a:fontRef idx="minor">
+            <a:schemeClr val="lt1"/>
+          </a:fontRef>
+        </p:style>
+        <p:txBody>
+          <a:bodyPr rtlCol="0" anchor="ctr"/>
+          <a:lstStyle/>
+          <a:p>
+            <a:pPr algn="ctr"/>
+            <a:r>
+              <a:rPr lang="en-US" sz="1600" dirty="0">
+                <a:solidFill>
+                  <a:schemeClr val="tx1"/>
+                </a:solidFill>
+              </a:rPr>
+              <a:t>Footer: Address and copyright information</a:t>
+            </a:r>
+          </a:p>
+        </p:txBody>
+      </p:sp>
+      <p:sp>
+        <p:nvSpPr>
+          <p:cNvPr id="22" name="TextBox 21">
+            <a:extLst>
+              <a:ext uri="{FF2B5EF4-FFF2-40B4-BE49-F238E27FC236}">
+                <a16:creationId xmlns:a16="http://schemas.microsoft.com/office/drawing/2014/main" id="{790DCA43-A01B-9E5D-E59F-9EF6D728E1B3}"/>
+              </a:ext>
+            </a:extLst>
+          </p:cNvPr>
+          <p:cNvSpPr txBox="1"/>
+          <p:nvPr/>
+        </p:nvSpPr>
+        <p:spPr>
+          <a:xfrm>
+            <a:off x="635056" y="6206564"/>
+            <a:ext cx="2491708" cy="338554"/>
+          </a:xfrm>
+          <a:prstGeom prst="rect">
+            <a:avLst/>
+          </a:prstGeom>
+          <a:noFill/>
+        </p:spPr>
+        <p:txBody>
+          <a:bodyPr wrap="none" rtlCol="0">
+            <a:spAutoFit/>
+          </a:bodyPr>
+          <a:lstStyle/>
+          <a:p>
+            <a:r>
+              <a:rPr lang="en-US" sz="1600" b="1" dirty="0"/>
+              <a:t>recent projects (a listing)</a:t>
+            </a:r>
+          </a:p>
+        </p:txBody>
+      </p:sp>
+      <p:sp>
+        <p:nvSpPr>
+          <p:cNvPr id="23" name="Rectangle 22">
+            <a:extLst>
+              <a:ext uri="{FF2B5EF4-FFF2-40B4-BE49-F238E27FC236}">
+                <a16:creationId xmlns:a16="http://schemas.microsoft.com/office/drawing/2014/main" id="{924AD071-C19C-6CCC-478E-F8FB1CE41CA5}"/>
+              </a:ext>
+            </a:extLst>
+          </p:cNvPr>
+          <p:cNvSpPr/>
+          <p:nvPr/>
+        </p:nvSpPr>
+        <p:spPr>
+          <a:xfrm>
+            <a:off x="681021" y="6566420"/>
+            <a:ext cx="2099113" cy="1858262"/>
+          </a:xfrm>
+          <a:prstGeom prst="rect">
+            <a:avLst/>
+          </a:prstGeom>
+          <a:solidFill>
+            <a:schemeClr val="accent6">
+              <a:lumMod val="40000"/>
+              <a:lumOff val="60000"/>
+            </a:schemeClr>
+          </a:solidFill>
+          <a:ln>
+            <a:noFill/>
+          </a:ln>
+        </p:spPr>
+        <p:style>
+          <a:lnRef idx="2">
+            <a:schemeClr val="accent1">
+              <a:shade val="15000"/>
+            </a:schemeClr>
+          </a:lnRef>
+          <a:fillRef idx="1">
+            <a:schemeClr val="accent1"/>
+          </a:fillRef>
+          <a:effectRef idx="0">
+            <a:schemeClr val="accent1"/>
+          </a:effectRef>
+          <a:fontRef idx="minor">
+            <a:schemeClr val="lt1"/>
+          </a:fontRef>
+        </p:style>
+        <p:txBody>
+          <a:bodyPr rtlCol="0" anchor="t"/>
+          <a:lstStyle/>
+          <a:p>
+            <a:r>
+              <a:rPr lang="en-US" sz="1600" dirty="0">
+                <a:solidFill>
+                  <a:schemeClr val="tx1"/>
+                </a:solidFill>
+              </a:rPr>
+              <a:t>project 1 intro text</a:t>
+            </a:r>
+          </a:p>
+        </p:txBody>
+      </p:sp>
+      <p:sp>
+        <p:nvSpPr>
+          <p:cNvPr id="24" name="Rectangle 23">
+            <a:extLst>
+              <a:ext uri="{FF2B5EF4-FFF2-40B4-BE49-F238E27FC236}">
+                <a16:creationId xmlns:a16="http://schemas.microsoft.com/office/drawing/2014/main" id="{8AE164E0-6C83-BB83-7275-76A78931141A}"/>
+              </a:ext>
+            </a:extLst>
+          </p:cNvPr>
+          <p:cNvSpPr/>
+          <p:nvPr/>
+        </p:nvSpPr>
+        <p:spPr>
+          <a:xfrm>
+            <a:off x="821882" y="7224206"/>
+            <a:ext cx="1852044" cy="1074666"/>
+          </a:xfrm>
+          <a:prstGeom prst="rect">
+            <a:avLst/>
+          </a:prstGeom>
+        </p:spPr>
+        <p:style>
+          <a:lnRef idx="2">
+            <a:schemeClr val="accent1">
+              <a:shade val="15000"/>
+            </a:schemeClr>
+          </a:lnRef>
+          <a:fillRef idx="1">
+            <a:schemeClr val="accent1"/>
+          </a:fillRef>
+          <a:effectRef idx="0">
+            <a:schemeClr val="accent1"/>
+          </a:effectRef>
+          <a:fontRef idx="minor">
+            <a:schemeClr val="lt1"/>
+          </a:fontRef>
+        </p:style>
+        <p:txBody>
+          <a:bodyPr rtlCol="0" anchor="ctr"/>
+          <a:lstStyle/>
+          <a:p>
+            <a:pPr algn="ctr"/>
+            <a:r>
+              <a:rPr lang="en-US" sz="1600" dirty="0"/>
+              <a:t>proj01.png</a:t>
+            </a:r>
+          </a:p>
+        </p:txBody>
+      </p:sp>
+      <p:sp>
+        <p:nvSpPr>
+          <p:cNvPr id="25" name="Rectangle 24">
+            <a:extLst>
+              <a:ext uri="{FF2B5EF4-FFF2-40B4-BE49-F238E27FC236}">
+                <a16:creationId xmlns:a16="http://schemas.microsoft.com/office/drawing/2014/main" id="{FBB0FD6A-DF1E-5B84-260E-C7D42E3BB550}"/>
+              </a:ext>
+            </a:extLst>
+          </p:cNvPr>
+          <p:cNvSpPr/>
+          <p:nvPr/>
+        </p:nvSpPr>
+        <p:spPr>
+          <a:xfrm>
+            <a:off x="3325000" y="6576398"/>
+            <a:ext cx="2099113" cy="1858262"/>
+          </a:xfrm>
+          <a:prstGeom prst="rect">
+            <a:avLst/>
+          </a:prstGeom>
+          <a:solidFill>
+            <a:schemeClr val="accent6">
+              <a:lumMod val="40000"/>
+              <a:lumOff val="60000"/>
+            </a:schemeClr>
+          </a:solidFill>
+          <a:ln>
+            <a:noFill/>
+          </a:ln>
+        </p:spPr>
+        <p:style>
+          <a:lnRef idx="2">
+            <a:schemeClr val="accent1">
+              <a:shade val="15000"/>
+            </a:schemeClr>
+          </a:lnRef>
+          <a:fillRef idx="1">
+            <a:schemeClr val="accent1"/>
+          </a:fillRef>
+          <a:effectRef idx="0">
+            <a:schemeClr val="accent1"/>
+          </a:effectRef>
+          <a:fontRef idx="minor">
+            <a:schemeClr val="lt1"/>
+          </a:fontRef>
+        </p:style>
+        <p:txBody>
+          <a:bodyPr rtlCol="0" anchor="t"/>
+          <a:lstStyle/>
+          <a:p>
+            <a:r>
+              <a:rPr lang="en-US" sz="1600" dirty="0">
+                <a:solidFill>
+                  <a:schemeClr val="tx1"/>
+                </a:solidFill>
+              </a:rPr>
+              <a:t>project 2 intro text</a:t>
+            </a:r>
+          </a:p>
+        </p:txBody>
+      </p:sp>
+      <p:sp>
+        <p:nvSpPr>
+          <p:cNvPr id="26" name="Rectangle 25">
+            <a:extLst>
+              <a:ext uri="{FF2B5EF4-FFF2-40B4-BE49-F238E27FC236}">
+                <a16:creationId xmlns:a16="http://schemas.microsoft.com/office/drawing/2014/main" id="{59A3BA54-3FDA-F26D-3E14-60EAA225D36D}"/>
+              </a:ext>
+            </a:extLst>
+          </p:cNvPr>
+          <p:cNvSpPr/>
+          <p:nvPr/>
+        </p:nvSpPr>
+        <p:spPr>
+          <a:xfrm>
+            <a:off x="3468892" y="7234184"/>
+            <a:ext cx="1852044" cy="1074666"/>
+          </a:xfrm>
+          <a:prstGeom prst="rect">
+            <a:avLst/>
+          </a:prstGeom>
+        </p:spPr>
+        <p:style>
+          <a:lnRef idx="2">
+            <a:schemeClr val="accent1">
+              <a:shade val="15000"/>
+            </a:schemeClr>
+          </a:lnRef>
+          <a:fillRef idx="1">
+            <a:schemeClr val="accent1"/>
+          </a:fillRef>
+          <a:effectRef idx="0">
+            <a:schemeClr val="accent1"/>
+          </a:effectRef>
+          <a:fontRef idx="minor">
+            <a:schemeClr val="lt1"/>
+          </a:fontRef>
+        </p:style>
+        <p:txBody>
+          <a:bodyPr rtlCol="0" anchor="ctr"/>
+          <a:lstStyle/>
+          <a:p>
+            <a:pPr algn="ctr"/>
+            <a:r>
+              <a:rPr lang="en-US" sz="1600" dirty="0"/>
+              <a:t>proj02.png</a:t>
+            </a:r>
+          </a:p>
+        </p:txBody>
+      </p:sp>
+      <p:sp>
+        <p:nvSpPr>
+          <p:cNvPr id="27" name="Rectangle 26">
+            <a:extLst>
+              <a:ext uri="{FF2B5EF4-FFF2-40B4-BE49-F238E27FC236}">
+                <a16:creationId xmlns:a16="http://schemas.microsoft.com/office/drawing/2014/main" id="{8E8E527D-E2A7-4D08-8260-0CE9A605F10A}"/>
+              </a:ext>
+            </a:extLst>
+          </p:cNvPr>
+          <p:cNvSpPr/>
+          <p:nvPr/>
+        </p:nvSpPr>
+        <p:spPr>
+          <a:xfrm>
+            <a:off x="5979912" y="6566420"/>
+            <a:ext cx="2099113" cy="1858262"/>
+          </a:xfrm>
+          <a:prstGeom prst="rect">
+            <a:avLst/>
+          </a:prstGeom>
+          <a:solidFill>
+            <a:schemeClr val="accent6">
+              <a:lumMod val="40000"/>
+              <a:lumOff val="60000"/>
+            </a:schemeClr>
+          </a:solidFill>
+          <a:ln>
+            <a:noFill/>
+          </a:ln>
+        </p:spPr>
+        <p:style>
+          <a:lnRef idx="2">
+            <a:schemeClr val="accent1">
+              <a:shade val="15000"/>
+            </a:schemeClr>
+          </a:lnRef>
+          <a:fillRef idx="1">
+            <a:schemeClr val="accent1"/>
+          </a:fillRef>
+          <a:effectRef idx="0">
+            <a:schemeClr val="accent1"/>
+          </a:effectRef>
+          <a:fontRef idx="minor">
+            <a:schemeClr val="lt1"/>
+          </a:fontRef>
+        </p:style>
+        <p:txBody>
+          <a:bodyPr rtlCol="0" anchor="t"/>
+          <a:lstStyle/>
+          <a:p>
+            <a:r>
+              <a:rPr lang="en-US" sz="1600" dirty="0">
+                <a:solidFill>
+                  <a:schemeClr val="tx1"/>
+                </a:solidFill>
+              </a:rPr>
+              <a:t>project 3 intro text</a:t>
+            </a:r>
+          </a:p>
+        </p:txBody>
+      </p:sp>
+      <p:sp>
+        <p:nvSpPr>
+          <p:cNvPr id="28" name="Rectangle 27">
+            <a:extLst>
+              <a:ext uri="{FF2B5EF4-FFF2-40B4-BE49-F238E27FC236}">
+                <a16:creationId xmlns:a16="http://schemas.microsoft.com/office/drawing/2014/main" id="{A579110F-9933-7CC1-D7F5-E0B9BA343C0E}"/>
+              </a:ext>
+            </a:extLst>
+          </p:cNvPr>
+          <p:cNvSpPr/>
+          <p:nvPr/>
+        </p:nvSpPr>
+        <p:spPr>
+          <a:xfrm>
+            <a:off x="6103444" y="7234184"/>
+            <a:ext cx="1852044" cy="1074666"/>
+          </a:xfrm>
+          <a:prstGeom prst="rect">
+            <a:avLst/>
+          </a:prstGeom>
+        </p:spPr>
+        <p:style>
+          <a:lnRef idx="2">
+            <a:schemeClr val="accent1">
+              <a:shade val="15000"/>
+            </a:schemeClr>
+          </a:lnRef>
+          <a:fillRef idx="1">
+            <a:schemeClr val="accent1"/>
+          </a:fillRef>
+          <a:effectRef idx="0">
+            <a:schemeClr val="accent1"/>
+          </a:effectRef>
+          <a:fontRef idx="minor">
+            <a:schemeClr val="lt1"/>
+          </a:fontRef>
+        </p:style>
+        <p:txBody>
+          <a:bodyPr rtlCol="0" anchor="ctr"/>
+          <a:lstStyle/>
+          <a:p>
+            <a:pPr algn="ctr"/>
+            <a:r>
+              <a:rPr lang="en-US" sz="1600" dirty="0"/>
+              <a:t>proj03.png</a:t>
+            </a:r>
+          </a:p>
+        </p:txBody>
+      </p:sp>
+      <p:sp>
+        <p:nvSpPr>
+          <p:cNvPr id="29" name="Rectangle 28">
+            <a:extLst>
+              <a:ext uri="{FF2B5EF4-FFF2-40B4-BE49-F238E27FC236}">
+                <a16:creationId xmlns:a16="http://schemas.microsoft.com/office/drawing/2014/main" id="{E417008A-60E1-A24B-AD7F-1134431922AD}"/>
+              </a:ext>
+            </a:extLst>
+          </p:cNvPr>
+          <p:cNvSpPr/>
+          <p:nvPr/>
+        </p:nvSpPr>
+        <p:spPr>
+          <a:xfrm>
+            <a:off x="681022" y="3766982"/>
+            <a:ext cx="4089750" cy="2234657"/>
+          </a:xfrm>
+          <a:prstGeom prst="rect">
+            <a:avLst/>
+          </a:prstGeom>
+          <a:solidFill>
+            <a:schemeClr val="accent6">
+              <a:lumMod val="40000"/>
+              <a:lumOff val="60000"/>
+            </a:schemeClr>
+          </a:solidFill>
+          <a:ln>
+            <a:noFill/>
+          </a:ln>
+        </p:spPr>
+        <p:style>
+          <a:lnRef idx="2">
+            <a:schemeClr val="accent1">
+              <a:shade val="15000"/>
+            </a:schemeClr>
+          </a:lnRef>
+          <a:fillRef idx="1">
+            <a:schemeClr val="accent1"/>
+          </a:fillRef>
+          <a:effectRef idx="0">
+            <a:schemeClr val="accent1"/>
+          </a:effectRef>
+          <a:fontRef idx="minor">
+            <a:schemeClr val="lt1"/>
+          </a:fontRef>
+        </p:style>
+        <p:txBody>
+          <a:bodyPr rtlCol="0" anchor="t"/>
+          <a:lstStyle/>
+          <a:p>
+            <a:r>
+              <a:rPr lang="en-US" sz="1600" b="1" dirty="0">
+                <a:solidFill>
+                  <a:schemeClr val="tx1"/>
+                </a:solidFill>
+              </a:rPr>
+              <a:t>latest lab news</a:t>
+            </a:r>
+          </a:p>
+          <a:p>
+            <a:endParaRPr lang="en-US" sz="1600" dirty="0">
+              <a:solidFill>
+                <a:schemeClr val="tx1"/>
+              </a:solidFill>
+            </a:endParaRPr>
+          </a:p>
+          <a:p>
+            <a:r>
+              <a:rPr lang="en-US" sz="1600" dirty="0">
+                <a:solidFill>
+                  <a:schemeClr val="tx1"/>
+                </a:solidFill>
+              </a:rPr>
+              <a:t>[white background and black text]</a:t>
+            </a:r>
+          </a:p>
+        </p:txBody>
+      </p:sp>
+      <p:sp>
+        <p:nvSpPr>
+          <p:cNvPr id="16" name="Rectangle 15">
+            <a:extLst>
+              <a:ext uri="{FF2B5EF4-FFF2-40B4-BE49-F238E27FC236}">
+                <a16:creationId xmlns:a16="http://schemas.microsoft.com/office/drawing/2014/main" id="{D4F54AF5-8C72-36B9-04F6-F71D38C73798}"/>
+              </a:ext>
+            </a:extLst>
+          </p:cNvPr>
+          <p:cNvSpPr/>
+          <p:nvPr/>
+        </p:nvSpPr>
+        <p:spPr>
+          <a:xfrm>
+            <a:off x="4877208" y="3951009"/>
+            <a:ext cx="3225447" cy="1912909"/>
+          </a:xfrm>
+          <a:prstGeom prst="rect">
+            <a:avLst/>
+          </a:prstGeom>
+        </p:spPr>
+        <p:style>
+          <a:lnRef idx="2">
+            <a:schemeClr val="accent1">
+              <a:shade val="15000"/>
+            </a:schemeClr>
+          </a:lnRef>
+          <a:fillRef idx="1">
+            <a:schemeClr val="accent1"/>
+          </a:fillRef>
+          <a:effectRef idx="0">
+            <a:schemeClr val="accent1"/>
+          </a:effectRef>
+          <a:fontRef idx="minor">
+            <a:schemeClr val="lt1"/>
+          </a:fontRef>
+        </p:style>
+        <p:txBody>
+          <a:bodyPr rtlCol="0" anchor="ctr"/>
+          <a:lstStyle/>
+          <a:p>
+            <a:pPr algn="ctr"/>
+            <a:r>
+              <a:rPr lang="en-US" sz="1600" dirty="0"/>
+              <a:t>latest_graphic.png</a:t>
+            </a:r>
+          </a:p>
+        </p:txBody>
+      </p:sp>
+      <p:pic>
+        <p:nvPicPr>
+          <p:cNvPr id="14" name="Picture 13" descr="A silhouette of a bird&#10;&#10;AI-generated content may be incorrect.">
+            <a:extLst>
+              <a:ext uri="{FF2B5EF4-FFF2-40B4-BE49-F238E27FC236}">
+                <a16:creationId xmlns:a16="http://schemas.microsoft.com/office/drawing/2014/main" id="{36E92C4B-AD73-74A5-3F57-29803070A293}"/>
+              </a:ext>
+            </a:extLst>
+          </p:cNvPr>
+          <p:cNvPicPr>
+            <a:picLocks noChangeAspect="1"/>
+          </p:cNvPicPr>
+          <p:nvPr/>
+        </p:nvPicPr>
+        <p:blipFill>
+          <a:blip r:embed="rId2">
+            <a:extLst>
+              <a:ext uri="{28A0092B-C50C-407E-A947-70E740481C1C}">
+                <a14:useLocalDpi xmlns:a14="http://schemas.microsoft.com/office/drawing/2010/main" val="0"/>
+              </a:ext>
+            </a:extLst>
+          </a:blip>
+          <a:srcRect l="56111"/>
+          <a:stretch>
+            <a:fillRect/>
+          </a:stretch>
+        </p:blipFill>
+        <p:spPr>
+          <a:xfrm>
+            <a:off x="411521" y="422865"/>
+            <a:ext cx="1202600" cy="419578"/>
+          </a:xfrm>
+          <a:prstGeom prst="rect">
+            <a:avLst/>
+          </a:prstGeom>
+        </p:spPr>
+      </p:pic>
+      <p:sp>
+        <p:nvSpPr>
+          <p:cNvPr id="15" name="TextBox 14">
+            <a:extLst>
+              <a:ext uri="{FF2B5EF4-FFF2-40B4-BE49-F238E27FC236}">
+                <a16:creationId xmlns:a16="http://schemas.microsoft.com/office/drawing/2014/main" id="{E20E67B2-500B-85D1-FE3E-7797340C7F98}"/>
+              </a:ext>
+            </a:extLst>
+          </p:cNvPr>
+          <p:cNvSpPr txBox="1"/>
+          <p:nvPr/>
+        </p:nvSpPr>
+        <p:spPr>
+          <a:xfrm>
+            <a:off x="1604397" y="121250"/>
+            <a:ext cx="2070099" cy="738664"/>
+          </a:xfrm>
+          <a:prstGeom prst="rect">
+            <a:avLst/>
+          </a:prstGeom>
+          <a:noFill/>
+        </p:spPr>
+        <p:txBody>
+          <a:bodyPr wrap="square" rtlCol="0">
+            <a:spAutoFit/>
+          </a:bodyPr>
+          <a:lstStyle/>
+          <a:p>
+            <a:r>
+              <a:rPr lang="en-US" sz="1400" b="1" dirty="0">
+                <a:solidFill>
+                  <a:schemeClr val="tx2">
+                    <a:lumMod val="50000"/>
+                    <a:lumOff val="50000"/>
+                  </a:schemeClr>
+                </a:solidFill>
+              </a:rPr>
+              <a:t>BEHAVIORAL COMPLEXITY LAB </a:t>
+            </a:r>
+          </a:p>
+          <a:p>
+            <a:r>
+              <a:rPr lang="en-US" sz="1400" dirty="0"/>
+              <a:t>University of Wyoming</a:t>
+            </a:r>
+          </a:p>
+        </p:txBody>
+      </p:sp>
+      <p:sp>
+        <p:nvSpPr>
+          <p:cNvPr id="18" name="Rectangle 17">
+            <a:extLst>
+              <a:ext uri="{FF2B5EF4-FFF2-40B4-BE49-F238E27FC236}">
+                <a16:creationId xmlns:a16="http://schemas.microsoft.com/office/drawing/2014/main" id="{957DED52-C6B3-682C-52B2-344DE6E99C63}"/>
+              </a:ext>
+            </a:extLst>
+          </p:cNvPr>
+          <p:cNvSpPr/>
+          <p:nvPr/>
+        </p:nvSpPr>
+        <p:spPr>
+          <a:xfrm>
+            <a:off x="821882" y="3000278"/>
+            <a:ext cx="7257143" cy="574562"/>
+          </a:xfrm>
+          <a:prstGeom prst="rect">
+            <a:avLst/>
+          </a:prstGeom>
+          <a:solidFill>
+            <a:schemeClr val="accent6">
+              <a:lumMod val="40000"/>
+              <a:lumOff val="60000"/>
+            </a:schemeClr>
+          </a:solidFill>
+          <a:ln>
+            <a:noFill/>
+          </a:ln>
+        </p:spPr>
+        <p:style>
+          <a:lnRef idx="2">
+            <a:schemeClr val="accent1">
+              <a:shade val="15000"/>
+            </a:schemeClr>
+          </a:lnRef>
+          <a:fillRef idx="1">
+            <a:schemeClr val="accent1"/>
+          </a:fillRef>
+          <a:effectRef idx="0">
+            <a:schemeClr val="accent1"/>
+          </a:effectRef>
+          <a:fontRef idx="minor">
+            <a:schemeClr val="lt1"/>
+          </a:fontRef>
+        </p:style>
+        <p:txBody>
+          <a:bodyPr rtlCol="0" anchor="t"/>
+          <a:lstStyle/>
+          <a:p>
+            <a:r>
+              <a:rPr lang="en-US" sz="1600" b="1" dirty="0">
+                <a:solidFill>
+                  <a:schemeClr val="tx1"/>
+                </a:solidFill>
+              </a:rPr>
+              <a:t>lab mission</a:t>
+            </a:r>
+          </a:p>
+          <a:p>
+            <a:r>
+              <a:rPr lang="en-US" sz="1600" dirty="0">
+                <a:solidFill>
+                  <a:schemeClr val="tx1"/>
+                </a:solidFill>
+              </a:rPr>
+              <a:t>[pale blue background and black text]</a:t>
+            </a:r>
+          </a:p>
+        </p:txBody>
+      </p:sp>
+      <p:sp>
+        <p:nvSpPr>
+          <p:cNvPr id="36" name="Rectangle 35">
+            <a:extLst>
+              <a:ext uri="{FF2B5EF4-FFF2-40B4-BE49-F238E27FC236}">
+                <a16:creationId xmlns:a16="http://schemas.microsoft.com/office/drawing/2014/main" id="{853CA270-F155-1A33-43D0-F3352666EB35}"/>
+              </a:ext>
+            </a:extLst>
+          </p:cNvPr>
+          <p:cNvSpPr/>
+          <p:nvPr/>
+        </p:nvSpPr>
+        <p:spPr>
+          <a:xfrm>
+            <a:off x="635056" y="3686633"/>
+            <a:ext cx="7467600" cy="2401697"/>
+          </a:xfrm>
+          <a:prstGeom prst="rect">
+            <a:avLst/>
+          </a:prstGeom>
+          <a:noFill/>
+          <a:ln w="28575">
+            <a:solidFill>
+              <a:srgbClr val="D816CA"/>
+            </a:solidFill>
+            <a:prstDash val="sysDash"/>
+          </a:ln>
+        </p:spPr>
+        <p:style>
+          <a:lnRef idx="2">
+            <a:schemeClr val="accent1">
+              <a:shade val="15000"/>
+            </a:schemeClr>
+          </a:lnRef>
+          <a:fillRef idx="1">
+            <a:schemeClr val="accent1"/>
+          </a:fillRef>
+          <a:effectRef idx="0">
+            <a:schemeClr val="accent1"/>
+          </a:effectRef>
+          <a:fontRef idx="minor">
+            <a:schemeClr val="lt1"/>
+          </a:fontRef>
+        </p:style>
+        <p:txBody>
+          <a:bodyPr rtlCol="0" anchor="ctr"/>
+          <a:lstStyle/>
+          <a:p>
+            <a:pPr algn="ctr"/>
+            <a:endParaRPr lang="en-US"/>
+          </a:p>
+        </p:txBody>
+      </p:sp>
+      <p:sp>
+        <p:nvSpPr>
+          <p:cNvPr id="37" name="Rectangle 36">
+            <a:extLst>
+              <a:ext uri="{FF2B5EF4-FFF2-40B4-BE49-F238E27FC236}">
+                <a16:creationId xmlns:a16="http://schemas.microsoft.com/office/drawing/2014/main" id="{CAC2F986-4269-72C7-0017-8527B19CF26A}"/>
+              </a:ext>
+            </a:extLst>
+          </p:cNvPr>
+          <p:cNvSpPr/>
+          <p:nvPr/>
+        </p:nvSpPr>
+        <p:spPr>
+          <a:xfrm>
+            <a:off x="635056" y="6165635"/>
+            <a:ext cx="7467600" cy="2369594"/>
+          </a:xfrm>
+          <a:prstGeom prst="rect">
+            <a:avLst/>
+          </a:prstGeom>
+          <a:noFill/>
+          <a:ln w="28575">
+            <a:solidFill>
+              <a:srgbClr val="D816CA"/>
+            </a:solidFill>
+            <a:prstDash val="sysDash"/>
+          </a:ln>
+        </p:spPr>
+        <p:style>
+          <a:lnRef idx="2">
+            <a:schemeClr val="accent1">
+              <a:shade val="15000"/>
+            </a:schemeClr>
+          </a:lnRef>
+          <a:fillRef idx="1">
+            <a:schemeClr val="accent1"/>
+          </a:fillRef>
+          <a:effectRef idx="0">
+            <a:schemeClr val="accent1"/>
+          </a:effectRef>
+          <a:fontRef idx="minor">
+            <a:schemeClr val="lt1"/>
+          </a:fontRef>
+        </p:style>
+        <p:txBody>
+          <a:bodyPr rtlCol="0" anchor="ctr"/>
+          <a:lstStyle/>
+          <a:p>
+            <a:pPr algn="ctr"/>
+            <a:endParaRPr lang="en-US"/>
+          </a:p>
+        </p:txBody>
+      </p:sp>
+      <p:sp>
+        <p:nvSpPr>
+          <p:cNvPr id="38" name="Rectangle 37">
+            <a:extLst>
+              <a:ext uri="{FF2B5EF4-FFF2-40B4-BE49-F238E27FC236}">
+                <a16:creationId xmlns:a16="http://schemas.microsoft.com/office/drawing/2014/main" id="{9F8AB86E-E01D-0EE8-FAC4-54507A467B78}"/>
+              </a:ext>
+            </a:extLst>
+          </p:cNvPr>
+          <p:cNvSpPr/>
+          <p:nvPr/>
+        </p:nvSpPr>
+        <p:spPr>
+          <a:xfrm>
+            <a:off x="213433" y="8612535"/>
+            <a:ext cx="8198729" cy="1001221"/>
+          </a:xfrm>
+          <a:prstGeom prst="rect">
+            <a:avLst/>
+          </a:prstGeom>
+          <a:noFill/>
+          <a:ln w="28575">
+            <a:solidFill>
+              <a:srgbClr val="D816CA"/>
+            </a:solidFill>
+            <a:prstDash val="sysDash"/>
+          </a:ln>
+        </p:spPr>
+        <p:style>
+          <a:lnRef idx="2">
+            <a:schemeClr val="accent1">
+              <a:shade val="15000"/>
+            </a:schemeClr>
+          </a:lnRef>
+          <a:fillRef idx="1">
+            <a:schemeClr val="accent1"/>
+          </a:fillRef>
+          <a:effectRef idx="0">
+            <a:schemeClr val="accent1"/>
+          </a:effectRef>
+          <a:fontRef idx="minor">
+            <a:schemeClr val="lt1"/>
+          </a:fontRef>
+        </p:style>
+        <p:txBody>
+          <a:bodyPr rtlCol="0" anchor="ctr"/>
+          <a:lstStyle/>
+          <a:p>
+            <a:pPr algn="ctr"/>
+            <a:endParaRPr lang="en-US"/>
+          </a:p>
+        </p:txBody>
+      </p:sp>
+      <p:sp>
+        <p:nvSpPr>
+          <p:cNvPr id="39" name="Rectangle 38">
+            <a:extLst>
+              <a:ext uri="{FF2B5EF4-FFF2-40B4-BE49-F238E27FC236}">
+                <a16:creationId xmlns:a16="http://schemas.microsoft.com/office/drawing/2014/main" id="{F8576E04-36F2-39E8-BBC4-CB0D57538B9B}"/>
+              </a:ext>
+            </a:extLst>
+          </p:cNvPr>
+          <p:cNvSpPr/>
+          <p:nvPr/>
+        </p:nvSpPr>
+        <p:spPr>
+          <a:xfrm>
+            <a:off x="635056" y="3017063"/>
+            <a:ext cx="7467600" cy="606993"/>
+          </a:xfrm>
+          <a:prstGeom prst="rect">
+            <a:avLst/>
+          </a:prstGeom>
+          <a:noFill/>
+          <a:ln w="28575">
+            <a:solidFill>
+              <a:srgbClr val="D816CA"/>
+            </a:solidFill>
+            <a:prstDash val="sysDash"/>
+          </a:ln>
+        </p:spPr>
+        <p:style>
+          <a:lnRef idx="2">
+            <a:schemeClr val="accent1">
+              <a:shade val="15000"/>
+            </a:schemeClr>
+          </a:lnRef>
+          <a:fillRef idx="1">
+            <a:schemeClr val="accent1"/>
+          </a:fillRef>
+          <a:effectRef idx="0">
+            <a:schemeClr val="accent1"/>
+          </a:effectRef>
+          <a:fontRef idx="minor">
+            <a:schemeClr val="lt1"/>
+          </a:fontRef>
+        </p:style>
+        <p:txBody>
+          <a:bodyPr rtlCol="0" anchor="ctr"/>
+          <a:lstStyle/>
+          <a:p>
+            <a:pPr algn="ctr"/>
+            <a:endParaRPr lang="en-US"/>
+          </a:p>
+        </p:txBody>
+      </p:sp>
+      <p:sp>
+        <p:nvSpPr>
+          <p:cNvPr id="41" name="Rectangle 40">
+            <a:extLst>
+              <a:ext uri="{FF2B5EF4-FFF2-40B4-BE49-F238E27FC236}">
+                <a16:creationId xmlns:a16="http://schemas.microsoft.com/office/drawing/2014/main" id="{60CF830D-3C45-0823-B087-2D7DC34C5E7C}"/>
+              </a:ext>
+            </a:extLst>
+          </p:cNvPr>
+          <p:cNvSpPr/>
+          <p:nvPr/>
+        </p:nvSpPr>
+        <p:spPr>
+          <a:xfrm>
+            <a:off x="320830" y="100211"/>
+            <a:ext cx="7937645" cy="813271"/>
+          </a:xfrm>
+          <a:prstGeom prst="rect">
+            <a:avLst/>
+          </a:prstGeom>
+          <a:noFill/>
+          <a:ln w="28575">
+            <a:solidFill>
+              <a:srgbClr val="D816CA"/>
+            </a:solidFill>
+            <a:prstDash val="sysDash"/>
+          </a:ln>
+        </p:spPr>
+        <p:style>
+          <a:lnRef idx="2">
+            <a:schemeClr val="accent1">
+              <a:shade val="15000"/>
+            </a:schemeClr>
+          </a:lnRef>
+          <a:fillRef idx="1">
+            <a:schemeClr val="accent1"/>
+          </a:fillRef>
+          <a:effectRef idx="0">
+            <a:schemeClr val="accent1"/>
+          </a:effectRef>
+          <a:fontRef idx="minor">
+            <a:schemeClr val="lt1"/>
+          </a:fontRef>
+        </p:style>
+        <p:txBody>
+          <a:bodyPr rtlCol="0" anchor="ctr"/>
+          <a:lstStyle/>
+          <a:p>
+            <a:pPr algn="ctr"/>
+            <a:endParaRPr lang="en-US"/>
+          </a:p>
+        </p:txBody>
+      </p:sp>
+      <p:sp>
+        <p:nvSpPr>
+          <p:cNvPr id="42" name="TextBox 41">
+            <a:extLst>
+              <a:ext uri="{FF2B5EF4-FFF2-40B4-BE49-F238E27FC236}">
+                <a16:creationId xmlns:a16="http://schemas.microsoft.com/office/drawing/2014/main" id="{974C7723-CDC1-8162-26D4-2FBDD6B7A375}"/>
+              </a:ext>
+            </a:extLst>
+          </p:cNvPr>
+          <p:cNvSpPr txBox="1"/>
+          <p:nvPr/>
+        </p:nvSpPr>
+        <p:spPr>
+          <a:xfrm>
+            <a:off x="-92792" y="289715"/>
+            <a:ext cx="349776" cy="461665"/>
+          </a:xfrm>
+          <a:prstGeom prst="rect">
+            <a:avLst/>
+          </a:prstGeom>
+          <a:noFill/>
+        </p:spPr>
+        <p:txBody>
+          <a:bodyPr wrap="none" rtlCol="0">
+            <a:spAutoFit/>
+          </a:bodyPr>
+          <a:lstStyle/>
+          <a:p>
+            <a:r>
+              <a:rPr lang="en-US" sz="2400" b="1" dirty="0">
+                <a:solidFill>
+                  <a:srgbClr val="D816CA"/>
+                </a:solidFill>
+              </a:rPr>
+              <a:t>1</a:t>
+            </a:r>
+          </a:p>
+        </p:txBody>
+      </p:sp>
+      <p:sp>
+        <p:nvSpPr>
+          <p:cNvPr id="43" name="TextBox 42">
+            <a:extLst>
+              <a:ext uri="{FF2B5EF4-FFF2-40B4-BE49-F238E27FC236}">
+                <a16:creationId xmlns:a16="http://schemas.microsoft.com/office/drawing/2014/main" id="{EC447125-5B6C-3DE6-B4D6-3E1BD404238F}"/>
+              </a:ext>
+            </a:extLst>
+          </p:cNvPr>
+          <p:cNvSpPr txBox="1"/>
+          <p:nvPr/>
+        </p:nvSpPr>
+        <p:spPr>
+          <a:xfrm>
+            <a:off x="31029" y="3267755"/>
+            <a:ext cx="349776" cy="461665"/>
+          </a:xfrm>
+          <a:prstGeom prst="rect">
+            <a:avLst/>
+          </a:prstGeom>
+          <a:noFill/>
+        </p:spPr>
+        <p:txBody>
+          <a:bodyPr wrap="none" rtlCol="0">
+            <a:spAutoFit/>
+          </a:bodyPr>
+          <a:lstStyle/>
+          <a:p>
+            <a:r>
+              <a:rPr lang="en-US" sz="2400" b="1" dirty="0">
+                <a:solidFill>
+                  <a:srgbClr val="D816CA"/>
+                </a:solidFill>
+              </a:rPr>
+              <a:t>3</a:t>
+            </a:r>
+          </a:p>
+        </p:txBody>
+      </p:sp>
+      <p:sp>
+        <p:nvSpPr>
+          <p:cNvPr id="44" name="TextBox 43">
+            <a:extLst>
+              <a:ext uri="{FF2B5EF4-FFF2-40B4-BE49-F238E27FC236}">
+                <a16:creationId xmlns:a16="http://schemas.microsoft.com/office/drawing/2014/main" id="{37CBF3C1-ED01-48FD-5204-55E5E53CBCC0}"/>
+              </a:ext>
+            </a:extLst>
+          </p:cNvPr>
+          <p:cNvSpPr txBox="1"/>
+          <p:nvPr/>
+        </p:nvSpPr>
+        <p:spPr>
+          <a:xfrm>
+            <a:off x="205917" y="4613388"/>
+            <a:ext cx="349776" cy="461665"/>
+          </a:xfrm>
+          <a:prstGeom prst="rect">
+            <a:avLst/>
+          </a:prstGeom>
+          <a:noFill/>
+        </p:spPr>
+        <p:txBody>
+          <a:bodyPr wrap="none" rtlCol="0">
+            <a:spAutoFit/>
+          </a:bodyPr>
+          <a:lstStyle/>
+          <a:p>
+            <a:r>
+              <a:rPr lang="en-US" sz="2400" b="1" dirty="0">
+                <a:solidFill>
+                  <a:srgbClr val="D816CA"/>
+                </a:solidFill>
+              </a:rPr>
+              <a:t>4</a:t>
+            </a:r>
+          </a:p>
+        </p:txBody>
+      </p:sp>
+      <p:sp>
+        <p:nvSpPr>
+          <p:cNvPr id="45" name="TextBox 44">
+            <a:extLst>
+              <a:ext uri="{FF2B5EF4-FFF2-40B4-BE49-F238E27FC236}">
+                <a16:creationId xmlns:a16="http://schemas.microsoft.com/office/drawing/2014/main" id="{4E5D0412-CE23-D391-8591-44A0BB330351}"/>
+              </a:ext>
+            </a:extLst>
+          </p:cNvPr>
+          <p:cNvSpPr txBox="1"/>
+          <p:nvPr/>
+        </p:nvSpPr>
+        <p:spPr>
+          <a:xfrm>
+            <a:off x="179072" y="7244162"/>
+            <a:ext cx="349776" cy="461665"/>
+          </a:xfrm>
+          <a:prstGeom prst="rect">
+            <a:avLst/>
+          </a:prstGeom>
+          <a:noFill/>
+        </p:spPr>
+        <p:txBody>
+          <a:bodyPr wrap="none" rtlCol="0">
+            <a:spAutoFit/>
+          </a:bodyPr>
+          <a:lstStyle/>
+          <a:p>
+            <a:r>
+              <a:rPr lang="en-US" sz="2400" b="1" dirty="0">
+                <a:solidFill>
+                  <a:srgbClr val="D816CA"/>
+                </a:solidFill>
+              </a:rPr>
+              <a:t>5</a:t>
+            </a:r>
+          </a:p>
+        </p:txBody>
+      </p:sp>
+      <p:sp>
+        <p:nvSpPr>
+          <p:cNvPr id="47" name="TextBox 46">
+            <a:extLst>
+              <a:ext uri="{FF2B5EF4-FFF2-40B4-BE49-F238E27FC236}">
+                <a16:creationId xmlns:a16="http://schemas.microsoft.com/office/drawing/2014/main" id="{5187CA29-7898-92D6-A93C-0D22366C2EA1}"/>
+              </a:ext>
+            </a:extLst>
+          </p:cNvPr>
+          <p:cNvSpPr txBox="1"/>
+          <p:nvPr/>
+        </p:nvSpPr>
+        <p:spPr>
+          <a:xfrm>
+            <a:off x="-92792" y="8894479"/>
+            <a:ext cx="349776" cy="461665"/>
+          </a:xfrm>
+          <a:prstGeom prst="rect">
+            <a:avLst/>
+          </a:prstGeom>
+          <a:noFill/>
+        </p:spPr>
+        <p:txBody>
+          <a:bodyPr wrap="square" rtlCol="0">
+            <a:spAutoFit/>
+          </a:bodyPr>
+          <a:lstStyle/>
+          <a:p>
+            <a:r>
+              <a:rPr lang="en-US" sz="2400" b="1" dirty="0">
+                <a:solidFill>
+                  <a:srgbClr val="D816CA"/>
+                </a:solidFill>
+              </a:rPr>
+              <a:t>6</a:t>
+            </a:r>
+          </a:p>
+        </p:txBody>
+      </p:sp>
+      <p:sp>
+        <p:nvSpPr>
+          <p:cNvPr id="7" name="Rectangle 6">
+            <a:extLst>
+              <a:ext uri="{FF2B5EF4-FFF2-40B4-BE49-F238E27FC236}">
+                <a16:creationId xmlns:a16="http://schemas.microsoft.com/office/drawing/2014/main" id="{616D84FE-81C6-4544-2099-A4CDF897BF20}"/>
+              </a:ext>
+            </a:extLst>
+          </p:cNvPr>
+          <p:cNvSpPr/>
+          <p:nvPr/>
+        </p:nvSpPr>
+        <p:spPr>
+          <a:xfrm>
+            <a:off x="681021" y="3827806"/>
+            <a:ext cx="3835499" cy="2036111"/>
+          </a:xfrm>
+          <a:prstGeom prst="rect">
+            <a:avLst/>
+          </a:prstGeom>
+          <a:noFill/>
+          <a:ln w="28575">
+            <a:solidFill>
+              <a:srgbClr val="FF9933"/>
+            </a:solidFill>
+            <a:prstDash val="sysDash"/>
+          </a:ln>
+        </p:spPr>
+        <p:style>
+          <a:lnRef idx="2">
+            <a:schemeClr val="accent1">
+              <a:shade val="15000"/>
+            </a:schemeClr>
+          </a:lnRef>
+          <a:fillRef idx="1">
+            <a:schemeClr val="accent1"/>
+          </a:fillRef>
+          <a:effectRef idx="0">
+            <a:schemeClr val="accent1"/>
+          </a:effectRef>
+          <a:fontRef idx="minor">
+            <a:schemeClr val="lt1"/>
+          </a:fontRef>
+        </p:style>
+        <p:txBody>
+          <a:bodyPr rtlCol="0" anchor="ctr"/>
+          <a:lstStyle/>
+          <a:p>
+            <a:pPr algn="ctr"/>
+            <a:endParaRPr lang="en-US"/>
+          </a:p>
+        </p:txBody>
+      </p:sp>
+      <p:pic>
+        <p:nvPicPr>
+          <p:cNvPr id="9" name="Picture 8" descr="A silhouette of a bird&#10;&#10;AI-generated content may be incorrect.">
+            <a:extLst>
+              <a:ext uri="{FF2B5EF4-FFF2-40B4-BE49-F238E27FC236}">
+                <a16:creationId xmlns:a16="http://schemas.microsoft.com/office/drawing/2014/main" id="{C9B7176C-BB64-0DB9-C5DC-E71F619F6DC0}"/>
+              </a:ext>
+            </a:extLst>
+          </p:cNvPr>
+          <p:cNvPicPr>
+            <a:picLocks noChangeAspect="1"/>
+          </p:cNvPicPr>
+          <p:nvPr/>
+        </p:nvPicPr>
+        <p:blipFill>
+          <a:blip r:embed="rId2">
+            <a:extLst>
+              <a:ext uri="{28A0092B-C50C-407E-A947-70E740481C1C}">
+                <a14:useLocalDpi xmlns:a14="http://schemas.microsoft.com/office/drawing/2010/main" val="0"/>
+              </a:ext>
+            </a:extLst>
+          </a:blip>
+          <a:srcRect r="44913"/>
+          <a:stretch>
+            <a:fillRect/>
+          </a:stretch>
+        </p:blipFill>
+        <p:spPr>
+          <a:xfrm>
+            <a:off x="371675" y="122992"/>
+            <a:ext cx="1247023" cy="346637"/>
+          </a:xfrm>
+          <a:prstGeom prst="rect">
+            <a:avLst/>
+          </a:prstGeom>
+        </p:spPr>
+      </p:pic>
+      <p:sp>
+        <p:nvSpPr>
+          <p:cNvPr id="31" name="Rectangle 30">
+            <a:extLst>
+              <a:ext uri="{FF2B5EF4-FFF2-40B4-BE49-F238E27FC236}">
+                <a16:creationId xmlns:a16="http://schemas.microsoft.com/office/drawing/2014/main" id="{06BF1A71-04AE-978C-AEBA-08877925CD42}"/>
+              </a:ext>
+            </a:extLst>
+          </p:cNvPr>
+          <p:cNvSpPr/>
+          <p:nvPr/>
+        </p:nvSpPr>
+        <p:spPr>
+          <a:xfrm>
+            <a:off x="555694" y="998337"/>
+            <a:ext cx="7523332" cy="1813578"/>
+          </a:xfrm>
+          <a:prstGeom prst="rect">
+            <a:avLst/>
+          </a:prstGeom>
+          <a:solidFill>
+            <a:schemeClr val="accent6">
+              <a:lumMod val="40000"/>
+              <a:lumOff val="60000"/>
+            </a:schemeClr>
+          </a:solidFill>
+        </p:spPr>
+        <p:style>
+          <a:lnRef idx="2">
+            <a:schemeClr val="accent1">
+              <a:shade val="15000"/>
+            </a:schemeClr>
+          </a:lnRef>
+          <a:fillRef idx="1">
+            <a:schemeClr val="accent1"/>
+          </a:fillRef>
+          <a:effectRef idx="0">
+            <a:schemeClr val="accent1"/>
+          </a:effectRef>
+          <a:fontRef idx="minor">
+            <a:schemeClr val="lt1"/>
+          </a:fontRef>
+        </p:style>
+        <p:txBody>
+          <a:bodyPr rtlCol="0" anchor="ctr"/>
+          <a:lstStyle/>
+          <a:p>
+            <a:pPr algn="ctr"/>
+            <a:endParaRPr lang="en-US" dirty="0"/>
+          </a:p>
+        </p:txBody>
+      </p:sp>
+      <p:sp>
+        <p:nvSpPr>
+          <p:cNvPr id="33" name="TextBox 32">
+            <a:extLst>
+              <a:ext uri="{FF2B5EF4-FFF2-40B4-BE49-F238E27FC236}">
+                <a16:creationId xmlns:a16="http://schemas.microsoft.com/office/drawing/2014/main" id="{FEE76F40-DD30-8315-BFFC-24C0EEAF20EB}"/>
+              </a:ext>
+            </a:extLst>
+          </p:cNvPr>
+          <p:cNvSpPr txBox="1"/>
+          <p:nvPr/>
+        </p:nvSpPr>
+        <p:spPr>
+          <a:xfrm>
+            <a:off x="-60633" y="973901"/>
+            <a:ext cx="349776" cy="461665"/>
+          </a:xfrm>
+          <a:prstGeom prst="rect">
+            <a:avLst/>
+          </a:prstGeom>
+          <a:noFill/>
+        </p:spPr>
+        <p:txBody>
+          <a:bodyPr wrap="none" rtlCol="0">
+            <a:spAutoFit/>
+          </a:bodyPr>
+          <a:lstStyle/>
+          <a:p>
+            <a:r>
+              <a:rPr lang="en-US" sz="2400" b="1" dirty="0">
+                <a:solidFill>
+                  <a:srgbClr val="D816CA"/>
+                </a:solidFill>
+              </a:rPr>
+              <a:t>2</a:t>
+            </a:r>
+          </a:p>
+        </p:txBody>
+      </p:sp>
+      <p:sp>
+        <p:nvSpPr>
+          <p:cNvPr id="34" name="Rectangle 33">
+            <a:extLst>
+              <a:ext uri="{FF2B5EF4-FFF2-40B4-BE49-F238E27FC236}">
+                <a16:creationId xmlns:a16="http://schemas.microsoft.com/office/drawing/2014/main" id="{2CC2638D-0140-8349-D813-E42C2CD26B16}"/>
+              </a:ext>
+            </a:extLst>
+          </p:cNvPr>
+          <p:cNvSpPr/>
+          <p:nvPr/>
+        </p:nvSpPr>
+        <p:spPr>
+          <a:xfrm>
+            <a:off x="256985" y="981831"/>
+            <a:ext cx="8155178" cy="1979157"/>
+          </a:xfrm>
+          <a:prstGeom prst="rect">
+            <a:avLst/>
+          </a:prstGeom>
+          <a:noFill/>
+          <a:ln w="28575">
+            <a:solidFill>
+              <a:srgbClr val="D816CA"/>
+            </a:solidFill>
+            <a:prstDash val="sysDash"/>
+          </a:ln>
+        </p:spPr>
+        <p:style>
+          <a:lnRef idx="2">
+            <a:schemeClr val="accent1">
+              <a:shade val="15000"/>
+            </a:schemeClr>
+          </a:lnRef>
+          <a:fillRef idx="1">
+            <a:schemeClr val="accent1"/>
+          </a:fillRef>
+          <a:effectRef idx="0">
+            <a:schemeClr val="accent1"/>
+          </a:effectRef>
+          <a:fontRef idx="minor">
+            <a:schemeClr val="lt1"/>
+          </a:fontRef>
+        </p:style>
+        <p:txBody>
+          <a:bodyPr rtlCol="0" anchor="ctr"/>
+          <a:lstStyle/>
+          <a:p>
+            <a:pPr algn="ctr"/>
+            <a:endParaRPr lang="en-US"/>
+          </a:p>
+        </p:txBody>
+      </p:sp>
+      <p:sp>
+        <p:nvSpPr>
+          <p:cNvPr id="40" name="TextBox 39">
+            <a:extLst>
+              <a:ext uri="{FF2B5EF4-FFF2-40B4-BE49-F238E27FC236}">
+                <a16:creationId xmlns:a16="http://schemas.microsoft.com/office/drawing/2014/main" id="{240940B9-DA57-F323-462D-DF207B01D781}"/>
+              </a:ext>
+            </a:extLst>
+          </p:cNvPr>
+          <p:cNvSpPr txBox="1"/>
+          <p:nvPr/>
+        </p:nvSpPr>
+        <p:spPr>
+          <a:xfrm>
+            <a:off x="437934" y="2454072"/>
+            <a:ext cx="7100919" cy="369332"/>
+          </a:xfrm>
+          <a:prstGeom prst="rect">
+            <a:avLst/>
+          </a:prstGeom>
+          <a:noFill/>
+        </p:spPr>
+        <p:txBody>
+          <a:bodyPr wrap="square">
+            <a:spAutoFit/>
+          </a:bodyPr>
+          <a:lstStyle/>
+          <a:p>
+            <a:pPr algn="ctr"/>
+            <a:r>
+              <a:rPr lang="en-US" i="1" dirty="0"/>
+              <a:t>A blurry photo background extending entire width of browser window</a:t>
+            </a:r>
+          </a:p>
+        </p:txBody>
+      </p:sp>
+      <p:sp>
+        <p:nvSpPr>
+          <p:cNvPr id="46" name="Rectangle 45">
+            <a:extLst>
+              <a:ext uri="{FF2B5EF4-FFF2-40B4-BE49-F238E27FC236}">
+                <a16:creationId xmlns:a16="http://schemas.microsoft.com/office/drawing/2014/main" id="{80FABF82-F5E0-E2F6-B810-8C3625A83DAB}"/>
+              </a:ext>
+            </a:extLst>
+          </p:cNvPr>
+          <p:cNvSpPr/>
+          <p:nvPr/>
+        </p:nvSpPr>
+        <p:spPr>
+          <a:xfrm>
+            <a:off x="3560039" y="1138569"/>
+            <a:ext cx="4069727" cy="1315503"/>
+          </a:xfrm>
+          <a:prstGeom prst="rect">
+            <a:avLst/>
+          </a:prstGeom>
+          <a:solidFill>
+            <a:schemeClr val="accent1">
+              <a:lumMod val="75000"/>
+            </a:schemeClr>
+          </a:solidFill>
+          <a:ln>
+            <a:noFill/>
+          </a:ln>
+        </p:spPr>
+        <p:style>
+          <a:lnRef idx="2">
+            <a:schemeClr val="accent1">
+              <a:shade val="15000"/>
+            </a:schemeClr>
+          </a:lnRef>
+          <a:fillRef idx="1">
+            <a:schemeClr val="accent1"/>
+          </a:fillRef>
+          <a:effectRef idx="0">
+            <a:schemeClr val="accent1"/>
+          </a:effectRef>
+          <a:fontRef idx="minor">
+            <a:schemeClr val="lt1"/>
+          </a:fontRef>
+        </p:style>
+        <p:txBody>
+          <a:bodyPr rtlCol="0" anchor="t"/>
+          <a:lstStyle/>
+          <a:p>
+            <a:r>
+              <a:rPr lang="en-US" sz="1600" dirty="0">
+                <a:solidFill>
+                  <a:schemeClr val="bg1"/>
+                </a:solidFill>
+              </a:rPr>
+              <a:t>Slide carousel for images and text</a:t>
+            </a:r>
+          </a:p>
+        </p:txBody>
+      </p:sp>
+      <p:sp>
+        <p:nvSpPr>
+          <p:cNvPr id="48" name="Rectangle 47">
+            <a:extLst>
+              <a:ext uri="{FF2B5EF4-FFF2-40B4-BE49-F238E27FC236}">
+                <a16:creationId xmlns:a16="http://schemas.microsoft.com/office/drawing/2014/main" id="{F1F55050-9089-DC73-E70E-87A716F01C07}"/>
+              </a:ext>
+            </a:extLst>
+          </p:cNvPr>
+          <p:cNvSpPr/>
+          <p:nvPr/>
+        </p:nvSpPr>
+        <p:spPr>
+          <a:xfrm>
+            <a:off x="782397" y="1482068"/>
+            <a:ext cx="2760798" cy="545785"/>
+          </a:xfrm>
+          <a:prstGeom prst="rect">
+            <a:avLst/>
+          </a:prstGeom>
+          <a:solidFill>
+            <a:schemeClr val="bg1">
+              <a:lumMod val="85000"/>
+            </a:schemeClr>
+          </a:solidFill>
+          <a:ln>
+            <a:noFill/>
+          </a:ln>
+        </p:spPr>
+        <p:style>
+          <a:lnRef idx="2">
+            <a:schemeClr val="accent1">
+              <a:shade val="15000"/>
+            </a:schemeClr>
+          </a:lnRef>
+          <a:fillRef idx="1">
+            <a:schemeClr val="accent1"/>
+          </a:fillRef>
+          <a:effectRef idx="0">
+            <a:schemeClr val="accent1"/>
+          </a:effectRef>
+          <a:fontRef idx="minor">
+            <a:schemeClr val="lt1"/>
+          </a:fontRef>
+        </p:style>
+        <p:txBody>
+          <a:bodyPr rtlCol="0" anchor="ctr"/>
+          <a:lstStyle/>
+          <a:p>
+            <a:pPr algn="ctr"/>
+            <a:r>
+              <a:rPr lang="en-US" sz="1400" i="1" dirty="0">
+                <a:solidFill>
+                  <a:schemeClr val="tx1"/>
+                </a:solidFill>
+              </a:rPr>
+              <a:t>Sem-transparent box with text about the image in the carousel</a:t>
+            </a:r>
+          </a:p>
+        </p:txBody>
+      </p:sp>
+    </p:spTree>
+    <p:extLst>
+      <p:ext uri="{BB962C8B-B14F-4D97-AF65-F5344CB8AC3E}">
+        <p14:creationId xmlns:p14="http://schemas.microsoft.com/office/powerpoint/2010/main" val="4045895441"/>
       </p:ext>
     </p:extLst>
   </p:cSld>

</xml_diff>